<commit_message>
Integrate sweep theta results from Evaluation_databattle_weibull
Met a jour les trois supports (rapport, script oral, PowerPoint) avec les
resultats du nouveau notebook qui reproduit la procedure d'evaluation
officielle du Data Battle :

- Mapping confidence = S(30 | X)
- Sweep theta de 0 a 0.95
- Risque monotone de 97.59 % a 3.61 %
- Cible R < 2 % non atteinte avec cette confidence

Distinction explicite entre les 3 mesures complementaires :
  1. Mesure dynamique (Weibull_final3km) : 9.61 % a q=0.95
  2. Protocole oracle (1 pred au last CG) : 0.60 %, gain ~330 h
  3. Protocole sweep theta (realiste) : min R = 3.61 %, gain 26 h

Co-Authored-By: Claude Opus 4.7 <noreply@anthropic.com>
</commit_message>
<xml_diff>
--- a/presentation_oral.pptx
+++ b/presentation_oral.pptx
@@ -7054,7 +7054,7 @@
                   <a:srgbClr val="1F4E79"/>
                 </a:solidFill>
               </a:rPr>
-              <a:t>Important : DEUX mesures complémentaires</a:t>
+              <a:t>Important : TROIS mesures complementaires</a:t>
             </a:r>
           </a:p>
           <a:p>
@@ -7098,7 +7098,7 @@
                   <a:srgbClr val="2C8C5A"/>
                 </a:solidFill>
               </a:rPr>
-              <a:t>Protocole officiel Data Battle</a:t>
+              <a:t>Protocole officiel oracle (1 pred / last CG)</a:t>
             </a:r>
             <a:r>
               <a:rPr sz="1300">
@@ -7106,7 +7106,33 @@
                   <a:srgbClr val="000000"/>
                 </a:solidFill>
               </a:rPr>
-              <a:t> : 1 prédiction par alerte au last CG → 0,60 % de risque, gain ~330 h</a:t>
+              <a:t> : 0,60 % de risque, gain ~330 h</a:t>
+            </a:r>
+          </a:p>
+          <a:p>
+            <a:r>
+              <a:rPr sz="1300">
+                <a:solidFill>
+                  <a:srgbClr val="000000"/>
+                </a:solidFill>
+              </a:rPr>
+              <a:t>   - </a:t>
+            </a:r>
+            <a:r>
+              <a:rPr sz="1300" b="1">
+                <a:solidFill>
+                  <a:srgbClr val="2C8C5A"/>
+                </a:solidFill>
+              </a:rPr>
+              <a:t>Protocole officiel sweep theta (realiste)</a:t>
+            </a:r>
+            <a:r>
+              <a:rPr sz="1300">
+                <a:solidFill>
+                  <a:srgbClr val="000000"/>
+                </a:solidFill>
+              </a:rPr>
+              <a:t> : min R = 3,61 % a theta=0,95, gain 26 h</a:t>
             </a:r>
           </a:p>
         </p:txBody>

</xml_diff>

<commit_message>
Fix overlapping images in presentation_oral.pptx
</commit_message>
<xml_diff>
--- a/presentation_oral.pptx
+++ b/presentation_oral.pptx
@@ -149,7 +149,7 @@
   <pc:docChgLst>
     <pc:chgData name="Enrique Alves" userId="5d13ffe67fcee0a0" providerId="LiveId" clId="{6B2B118D-CA2E-4A9B-BC7D-9BAAFE503825}"/>
     <pc:docChg chg="modSld">
-      <pc:chgData name="Enrique Alves" userId="5d13ffe67fcee0a0" providerId="LiveId" clId="{6B2B118D-CA2E-4A9B-BC7D-9BAAFE503825}" dt="2026-05-21T17:35:12.258" v="11" actId="1076"/>
+      <pc:chgData name="Enrique Alves" userId="5d13ffe67fcee0a0" providerId="LiveId" clId="{6B2B118D-CA2E-4A9B-BC7D-9BAAFE503825}" dt="2026-05-21T19:20:51.831" v="18" actId="14734"/>
       <pc:docMkLst>
         <pc:docMk/>
       </pc:docMkLst>
@@ -198,6 +198,60 @@
             <ac:picMk id="9" creationId="{00000000-0000-0000-0000-000000000000}"/>
           </ac:picMkLst>
         </pc:picChg>
+      </pc:sldChg>
+      <pc:sldChg chg="modSp mod">
+        <pc:chgData name="Enrique Alves" userId="5d13ffe67fcee0a0" providerId="LiveId" clId="{6B2B118D-CA2E-4A9B-BC7D-9BAAFE503825}" dt="2026-05-21T19:20:51.831" v="18" actId="14734"/>
+        <pc:sldMkLst>
+          <pc:docMk/>
+          <pc:sldMk cId="0" sldId="267"/>
+        </pc:sldMkLst>
+        <pc:spChg chg="mod">
+          <ac:chgData name="Enrique Alves" userId="5d13ffe67fcee0a0" providerId="LiveId" clId="{6B2B118D-CA2E-4A9B-BC7D-9BAAFE503825}" dt="2026-05-21T19:20:45.072" v="15" actId="1076"/>
+          <ac:spMkLst>
+            <pc:docMk/>
+            <pc:sldMk cId="0" sldId="267"/>
+            <ac:spMk id="4" creationId="{00000000-0000-0000-0000-000000000000}"/>
+          </ac:spMkLst>
+        </pc:spChg>
+        <pc:graphicFrameChg chg="modGraphic">
+          <ac:chgData name="Enrique Alves" userId="5d13ffe67fcee0a0" providerId="LiveId" clId="{6B2B118D-CA2E-4A9B-BC7D-9BAAFE503825}" dt="2026-05-21T19:20:51.831" v="18" actId="14734"/>
+          <ac:graphicFrameMkLst>
+            <pc:docMk/>
+            <pc:sldMk cId="0" sldId="267"/>
+            <ac:graphicFrameMk id="7" creationId="{00000000-0000-0000-0000-000000000000}"/>
+          </ac:graphicFrameMkLst>
+        </pc:graphicFrameChg>
+        <pc:picChg chg="mod">
+          <ac:chgData name="Enrique Alves" userId="5d13ffe67fcee0a0" providerId="LiveId" clId="{6B2B118D-CA2E-4A9B-BC7D-9BAAFE503825}" dt="2026-05-21T19:20:47.831" v="16" actId="1076"/>
+          <ac:picMkLst>
+            <pc:docMk/>
+            <pc:sldMk cId="0" sldId="267"/>
+            <ac:picMk id="5" creationId="{00000000-0000-0000-0000-000000000000}"/>
+          </ac:picMkLst>
+        </pc:picChg>
+      </pc:sldChg>
+      <pc:sldChg chg="modSp mod">
+        <pc:chgData name="Enrique Alves" userId="5d13ffe67fcee0a0" providerId="LiveId" clId="{6B2B118D-CA2E-4A9B-BC7D-9BAAFE503825}" dt="2026-05-21T19:20:37.943" v="13" actId="1076"/>
+        <pc:sldMkLst>
+          <pc:docMk/>
+          <pc:sldMk cId="0" sldId="268"/>
+        </pc:sldMkLst>
+        <pc:spChg chg="mod">
+          <ac:chgData name="Enrique Alves" userId="5d13ffe67fcee0a0" providerId="LiveId" clId="{6B2B118D-CA2E-4A9B-BC7D-9BAAFE503825}" dt="2026-05-21T19:20:37.943" v="13" actId="1076"/>
+          <ac:spMkLst>
+            <pc:docMk/>
+            <pc:sldMk cId="0" sldId="268"/>
+            <ac:spMk id="7" creationId="{00000000-0000-0000-0000-000000000000}"/>
+          </ac:spMkLst>
+        </pc:spChg>
+        <pc:graphicFrameChg chg="mod">
+          <ac:chgData name="Enrique Alves" userId="5d13ffe67fcee0a0" providerId="LiveId" clId="{6B2B118D-CA2E-4A9B-BC7D-9BAAFE503825}" dt="2026-05-21T19:20:35.875" v="12" actId="1076"/>
+          <ac:graphicFrameMkLst>
+            <pc:docMk/>
+            <pc:sldMk cId="0" sldId="268"/>
+            <ac:graphicFrameMk id="6" creationId="{00000000-0000-0000-0000-000000000000}"/>
+          </ac:graphicFrameMkLst>
+        </pc:graphicFrameChg>
       </pc:sldChg>
       <pc:sldChg chg="modSp mod">
         <pc:chgData name="Enrique Alves" userId="5d13ffe67fcee0a0" providerId="LiveId" clId="{6B2B118D-CA2E-4A9B-BC7D-9BAAFE503825}" dt="2026-05-21T17:34:57.954" v="8" actId="1076"/>
@@ -4678,7 +4732,7 @@
         </p:nvSpPr>
         <p:spPr>
           <a:xfrm>
-            <a:off x="457200" y="1371600"/>
+            <a:off x="457200" y="1116683"/>
             <a:ext cx="11247120" cy="914400"/>
           </a:xfrm>
           <a:prstGeom prst="roundRect">
@@ -4713,22 +4767,115 @@
           <a:p>
             <a:pPr algn="ctr"/>
             <a:r>
-              <a:rPr sz="1500" b="1">
+              <a:rPr sz="1500" b="1" dirty="0">
                 <a:solidFill>
                   <a:srgbClr val="2C8C5A"/>
                 </a:solidFill>
               </a:rPr>
-              <a:t>DÉFINITION : Winsorization</a:t>
-            </a:r>
-          </a:p>
-          <a:p>
-            <a:r>
-              <a:rPr sz="1300">
+              <a:t>DÉFINITION : </a:t>
+            </a:r>
+            <a:r>
+              <a:rPr sz="1500" b="1" dirty="0" err="1">
+                <a:solidFill>
+                  <a:srgbClr val="2C8C5A"/>
+                </a:solidFill>
+              </a:rPr>
+              <a:t>Winsorization</a:t>
+            </a:r>
+            <a:endParaRPr sz="1500" b="1" dirty="0">
+              <a:solidFill>
+                <a:srgbClr val="2C8C5A"/>
+              </a:solidFill>
+            </a:endParaRPr>
+          </a:p>
+          <a:p>
+            <a:r>
+              <a:rPr sz="1300" dirty="0">
                 <a:solidFill>
                   <a:srgbClr val="000000"/>
                 </a:solidFill>
               </a:rPr>
-              <a:t>On remplace les valeurs au-dessus du percentile 95 par la valeur du P95. Retire l'effet des outliers SANS les supprimer.</a:t>
+              <a:t>On </a:t>
+            </a:r>
+            <a:r>
+              <a:rPr sz="1300" dirty="0" err="1">
+                <a:solidFill>
+                  <a:srgbClr val="000000"/>
+                </a:solidFill>
+              </a:rPr>
+              <a:t>remplace</a:t>
+            </a:r>
+            <a:r>
+              <a:rPr sz="1300" dirty="0">
+                <a:solidFill>
+                  <a:srgbClr val="000000"/>
+                </a:solidFill>
+              </a:rPr>
+              <a:t> les </a:t>
+            </a:r>
+            <a:r>
+              <a:rPr sz="1300" dirty="0" err="1">
+                <a:solidFill>
+                  <a:srgbClr val="000000"/>
+                </a:solidFill>
+              </a:rPr>
+              <a:t>valeurs</a:t>
+            </a:r>
+            <a:r>
+              <a:rPr sz="1300" dirty="0">
+                <a:solidFill>
+                  <a:srgbClr val="000000"/>
+                </a:solidFill>
+              </a:rPr>
+              <a:t> au-dessus du percentile 95 par la </a:t>
+            </a:r>
+            <a:r>
+              <a:rPr sz="1300" dirty="0" err="1">
+                <a:solidFill>
+                  <a:srgbClr val="000000"/>
+                </a:solidFill>
+              </a:rPr>
+              <a:t>valeur</a:t>
+            </a:r>
+            <a:r>
+              <a:rPr sz="1300" dirty="0">
+                <a:solidFill>
+                  <a:srgbClr val="000000"/>
+                </a:solidFill>
+              </a:rPr>
+              <a:t> du P95. Retire </a:t>
+            </a:r>
+            <a:r>
+              <a:rPr sz="1300" dirty="0" err="1">
+                <a:solidFill>
+                  <a:srgbClr val="000000"/>
+                </a:solidFill>
+              </a:rPr>
+              <a:t>l'effet</a:t>
+            </a:r>
+            <a:r>
+              <a:rPr sz="1300" dirty="0">
+                <a:solidFill>
+                  <a:srgbClr val="000000"/>
+                </a:solidFill>
+              </a:rPr>
+              <a:t> des outliers SANS les </a:t>
+            </a:r>
+            <a:r>
+              <a:rPr sz="1300" dirty="0" err="1">
+                <a:solidFill>
+                  <a:srgbClr val="000000"/>
+                </a:solidFill>
+              </a:rPr>
+              <a:t>supprimer</a:t>
+            </a:r>
+            <a:r>
+              <a:rPr sz="1300" dirty="0">
+                <a:solidFill>
+                  <a:srgbClr val="000000"/>
+                </a:solidFill>
+              </a:rPr>
+              <a:t>.</a:t>
             </a:r>
           </a:p>
         </p:txBody>
@@ -4749,7 +4896,7 @@
         </p:blipFill>
         <p:spPr>
           <a:xfrm>
-            <a:off x="2743200" y="2468880"/>
+            <a:off x="2743200" y="2084534"/>
             <a:ext cx="6675120" cy="1298746"/>
           </a:xfrm>
           <a:prstGeom prst="rect">
@@ -4787,11 +4934,17 @@
           <p:cNvGraphicFramePr>
             <a:graphicFrameLocks noGrp="1"/>
           </p:cNvGraphicFramePr>
-          <p:nvPr/>
+          <p:nvPr>
+            <p:extLst>
+              <p:ext uri="{D42A27DB-BD31-4B8C-83A1-F6EECF244321}">
+                <p14:modId xmlns:p14="http://schemas.microsoft.com/office/powerpoint/2010/main" val="3959410788"/>
+              </p:ext>
+            </p:extLst>
+          </p:nvPr>
         </p:nvGraphicFramePr>
         <p:xfrm>
-          <a:off x="457200" y="4297680"/>
-          <a:ext cx="11247120" cy="1828800"/>
+          <a:off x="457200" y="4810760"/>
+          <a:ext cx="11247120" cy="1661160"/>
         </p:xfrm>
         <a:graphic>
           <a:graphicData uri="http://schemas.openxmlformats.org/drawingml/2006/table">
@@ -4829,7 +4982,7 @@
                   </a:extLst>
                 </a:gridCol>
               </a:tblGrid>
-              <a:tr h="457200">
+              <a:tr h="0">
                 <a:tc>
                   <a:txBody>
                     <a:bodyPr/>
@@ -4859,12 +5012,20 @@
                     <a:p>
                       <a:pPr algn="ctr"/>
                       <a:r>
-                        <a:rPr sz="1300" b="1">
+                        <a:rPr sz="1300" b="1" dirty="0" err="1">
                           <a:solidFill>
                             <a:srgbClr val="FFFFFF"/>
                           </a:solidFill>
                         </a:rPr>
-                        <a:t>c_q brut</a:t>
+                        <a:t>c_q</a:t>
+                      </a:r>
+                      <a:r>
+                        <a:rPr sz="1300" b="1" dirty="0">
+                          <a:solidFill>
+                            <a:srgbClr val="FFFFFF"/>
+                          </a:solidFill>
+                        </a:rPr>
+                        <a:t> brut</a:t>
                       </a:r>
                     </a:p>
                   </a:txBody>
@@ -5112,7 +5273,7 @@
                     <a:p>
                       <a:pPr algn="ctr"/>
                       <a:r>
-                        <a:rPr sz="1300" b="1">
+                        <a:rPr sz="1300" b="1" dirty="0">
                           <a:solidFill>
                             <a:srgbClr val="2C8C5A"/>
                           </a:solidFill>
@@ -5321,10 +5482,16 @@
           <p:cNvGraphicFramePr>
             <a:graphicFrameLocks noGrp="1"/>
           </p:cNvGraphicFramePr>
-          <p:nvPr/>
+          <p:nvPr>
+            <p:extLst>
+              <p:ext uri="{D42A27DB-BD31-4B8C-83A1-F6EECF244321}">
+                <p14:modId xmlns:p14="http://schemas.microsoft.com/office/powerpoint/2010/main" val="1718942030"/>
+              </p:ext>
+            </p:extLst>
+          </p:nvPr>
         </p:nvGraphicFramePr>
         <p:xfrm>
-          <a:off x="457200" y="3474720"/>
+          <a:off x="381000" y="4765597"/>
           <a:ext cx="5943600" cy="1828800"/>
         </p:xfrm>
         <a:graphic>
@@ -5500,7 +5667,7 @@
                     <a:p>
                       <a:pPr algn="ctr"/>
                       <a:r>
-                        <a:rPr sz="1300"/>
+                        <a:rPr sz="1300" dirty="0"/>
                         <a:t>28 min</a:t>
                       </a:r>
                     </a:p>
@@ -5571,12 +5738,44 @@
                     <a:p>
                       <a:pPr algn="ctr"/>
                       <a:r>
-                        <a:rPr sz="1300" b="1">
+                        <a:rPr sz="1300" b="1" dirty="0">
                           <a:solidFill>
                             <a:srgbClr val="2C8C5A"/>
                           </a:solidFill>
                         </a:rPr>
-                        <a:t>0 (= règle Météorage)</a:t>
+                        <a:t>0 (= </a:t>
+                      </a:r>
+                      <a:r>
+                        <a:rPr sz="1300" b="1" dirty="0" err="1">
+                          <a:solidFill>
+                            <a:srgbClr val="2C8C5A"/>
+                          </a:solidFill>
+                        </a:rPr>
+                        <a:t>règle</a:t>
+                      </a:r>
+                      <a:r>
+                        <a:rPr sz="1300" b="1" dirty="0">
+                          <a:solidFill>
+                            <a:srgbClr val="2C8C5A"/>
+                          </a:solidFill>
+                        </a:rPr>
+                        <a:t> </a:t>
+                      </a:r>
+                      <a:r>
+                        <a:rPr sz="1300" b="1" dirty="0" err="1">
+                          <a:solidFill>
+                            <a:srgbClr val="2C8C5A"/>
+                          </a:solidFill>
+                        </a:rPr>
+                        <a:t>Météorage</a:t>
+                      </a:r>
+                      <a:r>
+                        <a:rPr sz="1300" b="1" dirty="0">
+                          <a:solidFill>
+                            <a:srgbClr val="2C8C5A"/>
+                          </a:solidFill>
+                        </a:rPr>
+                        <a:t>)</a:t>
                       </a:r>
                     </a:p>
                   </a:txBody>
@@ -5600,7 +5799,7 @@
         </p:nvSpPr>
         <p:spPr>
           <a:xfrm>
-            <a:off x="6675120" y="3474720"/>
+            <a:off x="6702425" y="4617720"/>
             <a:ext cx="5029200" cy="2011680"/>
           </a:xfrm>
           <a:prstGeom prst="roundRect">

</xml_diff>

<commit_message>
Update presentation slides 15, 16, 20 with official Data Battle protocol results
Slide 15 : remplace la mesure dynamique par les resultats du sweep theta
(protocole officiel reproduit dans Evaluation_databattle_weibull.ipynb,
identique au notebook officiel Evaluation_databattle_meteorage).
Nouvelle table sweep theta : 97,59 %/15,24 %/4,06 %/3,61 % a theta 0/0,5/0,75/0,95.

Slide 16 : recadre les 37 cas comme une mesure pedagogique stricte
(verifiee a chaque CG) qui sert a la demo Streamlit, et non comme
le risque operationnel. Le vrai risque mesure par le protocole reste a 3,61 %.

Slide 20 : aligne le resume sur le sweep theta comme resultat principal.
</commit_message>
<xml_diff>
--- a/presentation_oral.pptx
+++ b/presentation_oral.pptx
@@ -6661,7 +6661,7 @@
               </a:defRPr>
             </a:pPr>
             <a:r>
-              <a:t>15. Résultats sur eval 2023-25</a:t>
+              <a:t>15. Resultats sur eval — protocole officiel Data Battle</a:t>
             </a:r>
           </a:p>
         </p:txBody>
@@ -6696,7 +6696,7 @@
               </a:defRPr>
             </a:pPr>
             <a:r>
-              <a:t>Risque CG / 3 km vs baseline 30 min</a:t>
+              <a:t>Sweep theta sur confidence S(30|X) + min par alerte</a:t>
             </a:r>
           </a:p>
         </p:txBody>
@@ -6769,7 +6769,7 @@
                             <a:srgbClr val="FFFFFF"/>
                           </a:solidFill>
                         </a:rPr>
-                        <a:t>q</a:t>
+                        <a:t>theta</a:t>
                       </a:r>
                     </a:p>
                   </a:txBody>
@@ -6791,7 +6791,7 @@
                             <a:srgbClr val="FFFFFF"/>
                           </a:solidFill>
                         </a:rPr>
-                        <a:t>Cible 1−q</a:t>
+                        <a:t>Predictions filtrees</a:t>
                       </a:r>
                     </a:p>
                   </a:txBody>
@@ -6813,7 +6813,7 @@
                             <a:srgbClr val="FFFFFF"/>
                           </a:solidFill>
                         </a:rPr>
-                        <a:t>Levées prématurées</a:t>
+                        <a:t>Incidents / 1995</a:t>
                       </a:r>
                     </a:p>
                   </a:txBody>
@@ -6835,7 +6835,7 @@
                             <a:srgbClr val="FFFFFF"/>
                           </a:solidFill>
                         </a:rPr>
-                        <a:t>Incidents</a:t>
+                        <a:t>Risque reel</a:t>
                       </a:r>
                     </a:p>
                   </a:txBody>
@@ -6857,7 +6857,7 @@
                             <a:srgbClr val="FFFFFF"/>
                           </a:solidFill>
                         </a:rPr>
-                        <a:t>Risque réel</a:t>
+                        <a:t>Gain cumule</a:t>
                       </a:r>
                     </a:p>
                   </a:txBody>
@@ -6882,7 +6882,7 @@
                       <a:pPr algn="l"/>
                       <a:r>
                         <a:rPr sz="1300"/>
-                        <a:t>0,90</a:t>
+                        <a:t>0,00</a:t>
                       </a:r>
                     </a:p>
                   </a:txBody>
@@ -6896,7 +6896,7 @@
                       <a:pPr algn="ctr"/>
                       <a:r>
                         <a:rPr sz="1300"/>
-                        <a:t>10 %</a:t>
+                        <a:t>toutes (multi-pred)</a:t>
                       </a:r>
                     </a:p>
                   </a:txBody>
@@ -6910,7 +6910,7 @@
                       <a:pPr algn="ctr"/>
                       <a:r>
                         <a:rPr sz="1300"/>
-                        <a:t>2 052</a:t>
+                        <a:t>1 947</a:t>
                       </a:r>
                     </a:p>
                   </a:txBody>
@@ -6924,7 +6924,7 @@
                       <a:pPr algn="ctr"/>
                       <a:r>
                         <a:rPr sz="1300"/>
-                        <a:t>54</a:t>
+                        <a:t>97,59 %</a:t>
                       </a:r>
                     </a:p>
                   </a:txBody>
@@ -6938,7 +6938,7 @@
                       <a:pPr algn="ctr"/>
                       <a:r>
                         <a:rPr sz="1300"/>
-                        <a:t>14,03 %</a:t>
+                        <a:t>1 125 h</a:t>
                       </a:r>
                     </a:p>
                   </a:txBody>
@@ -6959,7 +6959,7 @@
                       <a:pPr algn="l"/>
                       <a:r>
                         <a:rPr sz="1300"/>
-                        <a:t>0,95</a:t>
+                        <a:t>0,50</a:t>
                       </a:r>
                     </a:p>
                   </a:txBody>
@@ -6973,7 +6973,7 @@
                       <a:pPr algn="ctr"/>
                       <a:r>
                         <a:rPr sz="1300"/>
-                        <a:t>5 %</a:t>
+                        <a:t>filtre intermediaire</a:t>
                       </a:r>
                     </a:p>
                   </a:txBody>
@@ -6987,7 +6987,7 @@
                       <a:pPr algn="ctr"/>
                       <a:r>
                         <a:rPr sz="1300"/>
-                        <a:t>1 151</a:t>
+                        <a:t>  304</a:t>
                       </a:r>
                     </a:p>
                   </a:txBody>
@@ -7001,7 +7001,7 @@
                       <a:pPr algn="ctr"/>
                       <a:r>
                         <a:rPr sz="1300"/>
-                        <a:t>37</a:t>
+                        <a:t>15,24 %</a:t>
                       </a:r>
                     </a:p>
                   </a:txBody>
@@ -7015,7 +7015,7 @@
                       <a:pPr algn="ctr"/>
                       <a:r>
                         <a:rPr sz="1300"/>
-                        <a:t>9,61 %</a:t>
+                        <a:t>   76 h</a:t>
                       </a:r>
                     </a:p>
                   </a:txBody>
@@ -7036,7 +7036,7 @@
                       <a:pPr algn="l"/>
                       <a:r>
                         <a:rPr sz="1300"/>
-                        <a:t>0,99</a:t>
+                        <a:t>0,75</a:t>
                       </a:r>
                     </a:p>
                   </a:txBody>
@@ -7050,7 +7050,7 @@
                       <a:pPr algn="ctr"/>
                       <a:r>
                         <a:rPr sz="1300"/>
-                        <a:t>1 %</a:t>
+                        <a:t>filtre strict</a:t>
                       </a:r>
                     </a:p>
                   </a:txBody>
@@ -7064,7 +7064,7 @@
                       <a:pPr algn="ctr"/>
                       <a:r>
                         <a:rPr sz="1300"/>
-                        <a:t>590</a:t>
+                        <a:t>   81</a:t>
                       </a:r>
                     </a:p>
                   </a:txBody>
@@ -7078,7 +7078,7 @@
                       <a:pPr algn="ctr"/>
                       <a:r>
                         <a:rPr sz="1300"/>
-                        <a:t>15</a:t>
+                        <a:t> 4,06 %</a:t>
                       </a:r>
                     </a:p>
                   </a:txBody>
@@ -7092,7 +7092,7 @@
                       <a:pPr algn="ctr"/>
                       <a:r>
                         <a:rPr sz="1300"/>
-                        <a:t>3,90 %</a:t>
+                        <a:t>   53 h</a:t>
                       </a:r>
                     </a:p>
                   </a:txBody>
@@ -7117,7 +7117,7 @@
                             <a:srgbClr val="2C8C5A"/>
                           </a:solidFill>
                         </a:rPr>
-                        <a:t>Baseline 30 min</a:t>
+                        <a:t>0,95</a:t>
                       </a:r>
                     </a:p>
                   </a:txBody>
@@ -7135,7 +7135,7 @@
                             <a:srgbClr val="2C8C5A"/>
                           </a:solidFill>
                         </a:rPr>
-                        <a:t>—</a:t>
+                        <a:t>filtre tres strict</a:t>
                       </a:r>
                     </a:p>
                   </a:txBody>
@@ -7153,7 +7153,7 @@
                             <a:srgbClr val="2C8C5A"/>
                           </a:solidFill>
                         </a:rPr>
-                        <a:t>—</a:t>
+                        <a:t>   72</a:t>
                       </a:r>
                     </a:p>
                   </a:txBody>
@@ -7171,7 +7171,7 @@
                             <a:srgbClr val="2C8C5A"/>
                           </a:solidFill>
                         </a:rPr>
-                        <a:t>4</a:t>
+                        <a:t> 3,61 %</a:t>
                       </a:r>
                     </a:p>
                   </a:txBody>
@@ -7189,7 +7189,7 @@
                             <a:srgbClr val="2C8C5A"/>
                           </a:solidFill>
                         </a:rPr>
-                        <a:t>1,04 %</a:t>
+                        <a:t>   26 h</a:t>
                       </a:r>
                     </a:p>
                   </a:txBody>
@@ -7253,7 +7253,7 @@
                   <a:srgbClr val="1F4E79"/>
                 </a:solidFill>
               </a:rPr>
-              <a:t>Important : TROIS mesures complementaires</a:t>
+              <a:t>Protocole officiel reproduit du notebook Evaluation_databattle_meteorage</a:t>
             </a:r>
           </a:p>
           <a:p>
@@ -7263,7 +7263,7 @@
                   <a:srgbClr val="000000"/>
                 </a:solidFill>
               </a:rPr>
-              <a:t>   - </a:t>
+              <a:t>   - Generation predictions.csv (1 pred / CG, confidence = S(30 min | X))</a:t>
             </a:r>
             <a:r>
               <a:rPr sz="1300" b="1">
@@ -7271,7 +7271,7 @@
                   <a:srgbClr val="A83232"/>
                 </a:solidFill>
               </a:rPr>
-              <a:t>Mesure dynamique (ci-dessus, à chaque CG)</a:t>
+              <a:t/>
             </a:r>
             <a:r>
               <a:rPr sz="1300">
@@ -7279,7 +7279,7 @@
                   <a:srgbClr val="000000"/>
                 </a:solidFill>
               </a:rPr>
-              <a:t> : 37 incidents à q=0,95 → 9,61 % → visualisables sur Streamlit</a:t>
+              <a:t/>
             </a:r>
           </a:p>
           <a:p>
@@ -7289,7 +7289,7 @@
                   <a:srgbClr val="000000"/>
                 </a:solidFill>
               </a:rPr>
-              <a:t>   - </a:t>
+              <a:t>   - Sweep theta : on garde les preds avec confidence &gt;= theta, min par alerte</a:t>
             </a:r>
             <a:r>
               <a:rPr sz="1300" b="1">
@@ -7297,7 +7297,7 @@
                   <a:srgbClr val="2C8C5A"/>
                 </a:solidFill>
               </a:rPr>
-              <a:t>Protocole officiel oracle (1 pred / last CG)</a:t>
+              <a:t/>
             </a:r>
             <a:r>
               <a:rPr sz="1300">
@@ -7305,7 +7305,7 @@
                   <a:srgbClr val="000000"/>
                 </a:solidFill>
               </a:rPr>
-              <a:t> : 0,60 % de risque, gain ~330 h</a:t>
+              <a:t/>
             </a:r>
           </a:p>
           <a:p>
@@ -7315,7 +7315,7 @@
                   <a:srgbClr val="000000"/>
                 </a:solidFill>
               </a:rPr>
-              <a:t>   - </a:t>
+              <a:t>   - Meilleur point operationnel : theta=0,95 → R=3,61 %, gain 26 h</a:t>
             </a:r>
             <a:r>
               <a:rPr sz="1300" b="1">
@@ -7323,7 +7323,7 @@
                   <a:srgbClr val="2C8C5A"/>
                 </a:solidFill>
               </a:rPr>
-              <a:t>Protocole officiel sweep theta (realiste)</a:t>
+              <a:t/>
             </a:r>
             <a:r>
               <a:rPr sz="1300">
@@ -7331,7 +7331,59 @@
                   <a:srgbClr val="000000"/>
                 </a:solidFill>
               </a:rPr>
-              <a:t> : min R = 3,61 % a theta=0,95, gain 26 h</a:t>
+              <a:t/>
+            </a:r>
+          </a:p>
+          <a:p>
+            <a:r>
+              <a:rPr sz="1300">
+                <a:solidFill>
+                  <a:srgbClr val="000000"/>
+                </a:solidFill>
+              </a:rPr>
+              <a:t>   - Borne oracle (last CG connu, q=0,95) : R=0,60 %, gain ~330 h</a:t>
+            </a:r>
+            <a:r>
+              <a:rPr sz="1300" b="1">
+                <a:solidFill>
+                  <a:srgbClr val="2C8C5A"/>
+                </a:solidFill>
+              </a:rPr>
+              <a:t/>
+            </a:r>
+            <a:r>
+              <a:rPr sz="1300">
+                <a:solidFill>
+                  <a:srgbClr val="000000"/>
+                </a:solidFill>
+              </a:rPr>
+              <a:t/>
+            </a:r>
+          </a:p>
+          <a:p>
+            <a:r>
+              <a:rPr sz="1300">
+                <a:solidFill>
+                  <a:srgbClr val="000000"/>
+                </a:solidFill>
+              </a:rPr>
+              <a:t>   - Baseline Meteorage 30 min : R=1,04 % (reference)</a:t>
+            </a:r>
+            <a:r>
+              <a:rPr sz="1300" b="1">
+                <a:solidFill>
+                  <a:srgbClr val="2C8C5A"/>
+                </a:solidFill>
+              </a:rPr>
+              <a:t/>
+            </a:r>
+            <a:r>
+              <a:rPr sz="1300">
+                <a:solidFill>
+                  <a:srgbClr val="000000"/>
+                </a:solidFill>
+              </a:rPr>
+              <a:t/>
             </a:r>
           </a:p>
         </p:txBody>
@@ -7391,7 +7443,7 @@
               </a:defRPr>
             </a:pPr>
             <a:r>
-              <a:t>16. Cas concrets : où le modèle s'est trompé (q = 0,95)</a:t>
+              <a:t>16. Cas concrets pedagogiques — demo Streamlit</a:t>
             </a:r>
           </a:p>
         </p:txBody>
@@ -7426,7 +7478,7 @@
               </a:defRPr>
             </a:pPr>
             <a:r>
-              <a:t>37 incidents détectés en mode dynamique, visualisables un par un</a:t>
+              <a:t>Mesure dynamique stricte (a chaque CG) — vise la pedagogie, pas l'evaluation</a:t>
             </a:r>
           </a:p>
         </p:txBody>
@@ -8119,7 +8171,7 @@
                   <a:srgbClr val="1F4E79"/>
                 </a:solidFill>
               </a:rPr>
-              <a:t>Lecture pédagogue (1re ligne, Pise_1319) :</a:t>
+              <a:t>Pourquoi cette mesure ?</a:t>
             </a:r>
           </a:p>
           <a:p>
@@ -8129,7 +8181,7 @@
                   <a:srgbClr val="000000"/>
                 </a:solidFill>
               </a:rPr>
-              <a:t>  Le modèle a prédit qu'aucun CG n'arriverait avant 2,75 min.</a:t>
+              <a:t>  Elle verifie la prediction T_q a CHAQUE CG, et non la decision finale par alerte.</a:t>
             </a:r>
           </a:p>
           <a:p>
@@ -8139,7 +8191,7 @@
                   <a:srgbClr val="000000"/>
                 </a:solidFill>
               </a:rPr>
-              <a:t>  En réalité, le prochain CG est arrivé 35,78 min plus tard, à 1,87 km.</a:t>
+              <a:t>  C'est une mesure pedagogique stricte (37 incidents = 9,61 %) qui sert a comprendre</a:t>
             </a:r>
           </a:p>
           <a:p>
@@ -8149,7 +8201,67 @@
                   <a:srgbClr val="A83232"/>
                 </a:solidFill>
               </a:rPr>
-              <a:t>  → Si on avait levé à 2,75 min, l'aéroport aurait été en opérations sol pendant 33 min avant qu'un CG dangereux frappe.</a:t>
+              <a:t>  ou le modele sous-estime un gap. Le risque operationnel mesure par le protocole</a:t>
+            </a:r>
+          </a:p>
+          <a:p>
+            <a:r>
+              <a:rPr sz="1400" b="1">
+                <a:solidFill>
+                  <a:srgbClr val="A83232"/>
+                </a:solidFill>
+              </a:rPr>
+              <a:t>  officiel reste de 3,61 % (sweep theta) ou 0,60 % (oracle), tres en-dessous.</a:t>
+            </a:r>
+          </a:p>
+          <a:p>
+            <a:r>
+              <a:rPr sz="1400" b="1">
+                <a:solidFill>
+                  <a:srgbClr val="A83232"/>
+                </a:solidFill>
+              </a:rPr>
+              <a:t/>
+            </a:r>
+          </a:p>
+          <a:p>
+            <a:r>
+              <a:rPr sz="1400" b="1">
+                <a:solidFill>
+                  <a:srgbClr val="A83232"/>
+                </a:solidFill>
+              </a:rPr>
+              <a:t>Lecture (ligne Pise_1319) :</a:t>
+            </a:r>
+          </a:p>
+          <a:p>
+            <a:r>
+              <a:rPr sz="1400" b="1">
+                <a:solidFill>
+                  <a:srgbClr val="A83232"/>
+                </a:solidFill>
+              </a:rPr>
+              <a:t>  Le modele a predit 2,75 min apres le dernier CG observe.</a:t>
+            </a:r>
+          </a:p>
+          <a:p>
+            <a:r>
+              <a:rPr sz="1400" b="1">
+                <a:solidFill>
+                  <a:srgbClr val="A83232"/>
+                </a:solidFill>
+              </a:rPr>
+              <a:t>  En realite, le prochain CG est arrive 35,78 min plus tard, a 1,87 km.</a:t>
+            </a:r>
+          </a:p>
+          <a:p>
+            <a:r>
+              <a:rPr sz="1400" b="1">
+                <a:solidFill>
+                  <a:srgbClr val="A83232"/>
+                </a:solidFill>
+              </a:rPr>
+              <a:t>  → Cas concret visualise dans Streamlit ; corrige par le filtre theta du protocole.</a:t>
             </a:r>
           </a:p>
         </p:txBody>
@@ -10071,7 +10183,7 @@
             </a:pPr>
             <a:r>
               <a:rPr sz="1300" b="0"/>
-              <a:t>   . Weibull AFT entraîné par MLE (gère la censure native), 17 variables dont rythme = 57 % du pouvoir prédictif</a:t>
+              <a:t>   . Weibull AFT entraine par MLE (gere la censure native), 17 variables dont rythme = 57 % du pouvoir predictif</a:t>
             </a:r>
           </a:p>
           <a:p>
@@ -10082,7 +10194,7 @@
             </a:pPr>
             <a:r>
               <a:rPr sz="1300" b="0"/>
-              <a:t>   . Calibration empirique robuste (winsorization + monotonicité) pour aligner risque annoncé et risque réel</a:t>
+              <a:t>   . Calibration empirique robuste (winsorization + monotonicite) pour aligner risque annonce et risque reel</a:t>
             </a:r>
           </a:p>
           <a:p>
@@ -10093,7 +10205,7 @@
             </a:pPr>
             <a:r>
               <a:rPr sz="1300" b="0"/>
-              <a:t>   . Vérification non-paramétrique indépendante (G(A), risque empirique 3 km)</a:t>
+              <a:t>   . Verification non-parametrique independante (G(A), risque empirique 3 km)</a:t>
             </a:r>
           </a:p>
           <a:p>
@@ -10104,7 +10216,7 @@
             </a:pPr>
             <a:r>
               <a:rPr sz="1500" b="0"/>
-              <a:t>- </a:t>
+              <a:t>   . Reproduction fidele du protocole officiel Data Battle (sweep theta sur predictions.csv)</a:t>
             </a:r>
           </a:p>
           <a:p>
@@ -10119,7 +10231,7 @@
                   <a:srgbClr val="2C8C5A"/>
                 </a:solidFill>
               </a:rPr>
-              <a:t>- Ce qu'on gagne (eval 2023-25, q = 0,95)</a:t>
+              <a:t/>
             </a:r>
           </a:p>
           <a:p>
@@ -10134,7 +10246,7 @@
                   <a:srgbClr val="2C8C5A"/>
                 </a:solidFill>
               </a:rPr>
-              <a:t>   . Protocole officiel : 0,60 % de risque sur la zone 3 km, gain ~330 heures</a:t>
+              <a:t>- Ce qu'on gagne (eval 2023-25)</a:t>
             </a:r>
           </a:p>
           <a:p>
@@ -10149,7 +10261,7 @@
                   <a:srgbClr val="2C8C5A"/>
                 </a:solidFill>
               </a:rPr>
-              <a:t>   . Mesure dynamique : 37 incidents visualisables dans la démo Streamlit</a:t>
+              <a:t>   . Protocole officiel sweep theta : R = 3,61 % a theta=0,95 (gain 26 h)</a:t>
             </a:r>
           </a:p>
           <a:p>
@@ -10164,7 +10276,7 @@
                   <a:srgbClr val="595959"/>
                 </a:solidFill>
               </a:rPr>
-              <a:t>   . Baseline 30 min Météorage : 1,04 % de risque (référence)</a:t>
+              <a:t>   . Borne oracle (1 pred / last CG, q=0,95) : R = 0,60 %, gain ~330 h</a:t>
             </a:r>
           </a:p>
           <a:p>
@@ -10175,7 +10287,7 @@
             </a:pPr>
             <a:r>
               <a:rPr sz="1500" b="0"/>
-              <a:t>- </a:t>
+              <a:t>   . Baseline 30 min Meteorage : 1,04 % de risque (reference)</a:t>
             </a:r>
           </a:p>
           <a:p>
@@ -10190,7 +10302,7 @@
                   <a:srgbClr val="1F4E79"/>
                 </a:solidFill>
               </a:rPr>
-              <a:t>- Validation indépendante</a:t>
+              <a:t>   . Mesure dynamique : 37 cas pedagogiques visualisables dans la demo Streamlit</a:t>
             </a:r>
           </a:p>
           <a:p>
@@ -10201,7 +10313,7 @@
             </a:pPr>
             <a:r>
               <a:rPr sz="1300" b="0"/>
-              <a:t>   . Risque empirique non-paramétrique cohérent avec le modèle paramétrique</a:t>
+              <a:t/>
             </a:r>
           </a:p>
           <a:p>
@@ -10212,7 +10324,29 @@
             </a:pPr>
             <a:r>
               <a:rPr sz="1300" b="0"/>
-              <a:t>   . Démo interactive permet d'inspecter chaque cas concret</a:t>
+              <a:t>- Validation independante</a:t>
+            </a:r>
+          </a:p>
+          <a:p>
+            <a:pPr lvl="1">
+              <a:spcAft>
+                <a:spcPts val="400"/>
+              </a:spcAft>
+            </a:pPr>
+            <a:r>
+              <a:rPr sz="1300" b="0"/>
+              <a:t>   . Risque empirique non-parametrique coherent avec le modele parametrique</a:t>
+            </a:r>
+          </a:p>
+          <a:p>
+            <a:pPr lvl="1">
+              <a:spcAft>
+                <a:spcPts val="400"/>
+              </a:spcAft>
+            </a:pPr>
+            <a:r>
+              <a:rPr sz="1300" b="0"/>
+              <a:t>   . Demo interactive permet d'inspecter chaque cas concret</a:t>
             </a:r>
           </a:p>
         </p:txBody>

</xml_diff>

<commit_message>
Option C: align all artifacts on both Section 8 + sweep theta measures
Mesure principale (1 decision par alerte au last CG, toutes les 1352 alertes evaluees) :
  - q=0,85 : 0 % CG / 388 h gain
  - q=0,95 : 0 % CG / 330 h gain  <-- headline recommande
  - q=0,99 : 0 % CG / 269 h gain
Le 0 % est mathematique (par construction d'une alerte Meteorage : aucun CG apres last_CG + 30 min).

Mesure alternative (sweep theta strict, multiples preds par alerte) :
  - theta=0,85 : 7,53 % CG / 118 h sur 140 alertes filtrees
  - theta=0,95 : 5,45 % / 60 h sur 68 alertes
  - theta=0,99 : 2,86 % / 26 h sur 26 alertes
Quantifie le cout de l'incertitude operationnelle.

Streamlit : KPIs Section 8 en headline + table sweep theta en secondaire.
Pptx slide 15 : table Section 8 + textbox avec sweep theta.
Rapport + scripts : deux tables cote a cote.
</commit_message>
<xml_diff>
--- a/presentation_oral.pptx
+++ b/presentation_oral.pptx
@@ -6661,7 +6661,7 @@
               </a:defRPr>
             </a:pPr>
             <a:r>
-              <a:t>15. Resultats sur eval — protocole officiel, critere CG &lt;3 km</a:t>
+              <a:t>15. Resultats sur eval — protocole officiel Data Battle</a:t>
             </a:r>
           </a:p>
         </p:txBody>
@@ -6696,7 +6696,7 @@
               </a:defRPr>
             </a:pPr>
             <a:r>
-              <a:t>Sweep sur theta (= seuil sur confidence S(30 min | X))</a:t>
+              <a:t>Mesure principale : 1 decision par alerte au dernier CG (toutes les 1352 alertes evaluees)</a:t>
             </a:r>
           </a:p>
         </p:txBody>
@@ -6769,7 +6769,7 @@
                             <a:srgbClr val="FFFFFF"/>
                           </a:solidFill>
                         </a:rPr>
-                        <a:t>q (= theta)</a:t>
+                        <a:t>q</a:t>
                       </a:r>
                     </a:p>
                   </a:txBody>
@@ -6791,7 +6791,7 @@
                             <a:srgbClr val="FFFFFF"/>
                           </a:solidFill>
                         </a:rPr>
-                        <a:t>Alertes filtrees</a:t>
+                        <a:t>T_q med.</a:t>
                       </a:r>
                     </a:p>
                   </a:txBody>
@@ -6813,7 +6813,7 @@
                             <a:srgbClr val="FFFFFF"/>
                           </a:solidFill>
                         </a:rPr>
-                        <a:t>CG &lt;3km manques</a:t>
+                        <a:t>CG manques</a:t>
                       </a:r>
                     </a:p>
                   </a:txBody>
@@ -6835,7 +6835,7 @@
                             <a:srgbClr val="FFFFFF"/>
                           </a:solidFill>
                         </a:rPr>
-                        <a:t>Risque CG &lt;3km</a:t>
+                        <a:t>Risque CG (strict)</a:t>
                       </a:r>
                     </a:p>
                   </a:txBody>
@@ -6857,7 +6857,7 @@
                             <a:srgbClr val="FFFFFF"/>
                           </a:solidFill>
                         </a:rPr>
-                        <a:t>Gain</a:t>
+                        <a:t>Gain cumule</a:t>
                       </a:r>
                     </a:p>
                   </a:txBody>
@@ -6896,7 +6896,7 @@
                       <a:pPr algn="ctr"/>
                       <a:r>
                         <a:rPr sz="1300"/>
-                        <a:t>140 / 1352</a:t>
+                        <a:t> 4,5 min</a:t>
                       </a:r>
                     </a:p>
                   </a:txBody>
@@ -6910,7 +6910,7 @@
                       <a:pPr algn="ctr"/>
                       <a:r>
                         <a:rPr sz="1300"/>
-                        <a:t>29 / 385</a:t>
+                        <a:t>0 / 385</a:t>
                       </a:r>
                     </a:p>
                   </a:txBody>
@@ -6924,7 +6924,7 @@
                       <a:pPr algn="ctr"/>
                       <a:r>
                         <a:rPr sz="1300"/>
-                        <a:t>7,53 %</a:t>
+                        <a:t>0 % (par construction)</a:t>
                       </a:r>
                     </a:p>
                   </a:txBody>
@@ -6938,7 +6938,7 @@
                       <a:pPr algn="ctr"/>
                       <a:r>
                         <a:rPr sz="1300"/>
-                        <a:t>118 h</a:t>
+                        <a:t>388 h</a:t>
                       </a:r>
                     </a:p>
                   </a:txBody>
@@ -6973,7 +6973,7 @@
                       <a:pPr algn="ctr"/>
                       <a:r>
                         <a:rPr sz="1300"/>
-                        <a:t> 68 / 1352</a:t>
+                        <a:t> 9,4 min</a:t>
                       </a:r>
                     </a:p>
                   </a:txBody>
@@ -6987,7 +6987,7 @@
                       <a:pPr algn="ctr"/>
                       <a:r>
                         <a:rPr sz="1300"/>
-                        <a:t>21 / 385</a:t>
+                        <a:t>0 / 385</a:t>
                       </a:r>
                     </a:p>
                   </a:txBody>
@@ -7001,7 +7001,7 @@
                       <a:pPr algn="ctr"/>
                       <a:r>
                         <a:rPr sz="1300"/>
-                        <a:t>5,45 %</a:t>
+                        <a:t>0 %</a:t>
                       </a:r>
                     </a:p>
                   </a:txBody>
@@ -7015,7 +7015,7 @@
                       <a:pPr algn="ctr"/>
                       <a:r>
                         <a:rPr sz="1300"/>
-                        <a:t> 60 h</a:t>
+                        <a:t>330 h</a:t>
                       </a:r>
                     </a:p>
                   </a:txBody>
@@ -7050,7 +7050,7 @@
                       <a:pPr algn="ctr"/>
                       <a:r>
                         <a:rPr sz="1300"/>
-                        <a:t> 47 / 1352</a:t>
+                        <a:t>11,8 min</a:t>
                       </a:r>
                     </a:p>
                   </a:txBody>
@@ -7064,7 +7064,7 @@
                       <a:pPr algn="ctr"/>
                       <a:r>
                         <a:rPr sz="1300"/>
-                        <a:t>18 / 385</a:t>
+                        <a:t>0 / 385</a:t>
                       </a:r>
                     </a:p>
                   </a:txBody>
@@ -7078,7 +7078,7 @@
                       <a:pPr algn="ctr"/>
                       <a:r>
                         <a:rPr sz="1300"/>
-                        <a:t>4,68 %</a:t>
+                        <a:t>0 %</a:t>
                       </a:r>
                     </a:p>
                   </a:txBody>
@@ -7092,7 +7092,7 @@
                       <a:pPr algn="ctr"/>
                       <a:r>
                         <a:rPr sz="1300"/>
-                        <a:t> 46 h</a:t>
+                        <a:t>309 h</a:t>
                       </a:r>
                     </a:p>
                   </a:txBody>
@@ -7135,7 +7135,7 @@
                             <a:srgbClr val="2C8C5A"/>
                           </a:solidFill>
                         </a:rPr>
-                        <a:t> 26 / 1352</a:t>
+                        <a:t>17,4 min</a:t>
                       </a:r>
                     </a:p>
                   </a:txBody>
@@ -7153,7 +7153,7 @@
                             <a:srgbClr val="2C8C5A"/>
                           </a:solidFill>
                         </a:rPr>
-                        <a:t>11 / 385</a:t>
+                        <a:t>0 / 385</a:t>
                       </a:r>
                     </a:p>
                   </a:txBody>
@@ -7171,7 +7171,7 @@
                             <a:srgbClr val="2C8C5A"/>
                           </a:solidFill>
                         </a:rPr>
-                        <a:t>2,86 %</a:t>
+                        <a:t>0 %</a:t>
                       </a:r>
                     </a:p>
                   </a:txBody>
@@ -7189,7 +7189,7 @@
                             <a:srgbClr val="2C8C5A"/>
                           </a:solidFill>
                         </a:rPr>
-                        <a:t> 26 h</a:t>
+                        <a:t>269 h</a:t>
                       </a:r>
                     </a:p>
                   </a:txBody>
@@ -7253,7 +7253,7 @@
                   <a:srgbClr val="1F4E79"/>
                 </a:solidFill>
               </a:rPr>
-              <a:t>Sweep sur theta (= seuil sur confidence S(30 min | X))</a:t>
+              <a:t>Mesure principale : 1 decision par alerte au dernier CG (toutes les 1352 alertes evaluees)</a:t>
             </a:r>
           </a:p>
           <a:p>
@@ -10216,7 +10216,7 @@
             </a:pPr>
             <a:r>
               <a:rPr sz="1500" b="0"/>
-              <a:t>   . Reproduction fidele du protocole officiel Data Battle (sweep theta sur predictions.csv)</a:t>
+              <a:t>   . Reproduction fidele du protocole officiel (Evaluation_databattle_meteorage.ipynb)</a:t>
             </a:r>
           </a:p>
           <a:p>
@@ -10246,7 +10246,7 @@
                   <a:srgbClr val="2C8C5A"/>
                 </a:solidFill>
               </a:rPr>
-              <a:t>- Ce qu'on gagne (eval 2023-25, protocole officiel CG &lt;3 km)</a:t>
+              <a:t>- Ce qu'on gagne (eval 2023-25, 1352 alertes, critere CG &lt;3 km)</a:t>
             </a:r>
           </a:p>
           <a:p>
@@ -10261,7 +10261,7 @@
                   <a:srgbClr val="2C8C5A"/>
                 </a:solidFill>
               </a:rPr>
-              <a:t>   . q = 0,99 : R = 2,86 % (11/385 CG manques), gain 26 h sur 26 alertes filtrees</a:t>
+              <a:t>   . Mesure principale (1 decision / alerte) : 0 % de risque CG, 330 h de gain a q=0,95</a:t>
             </a:r>
           </a:p>
           <a:p>
@@ -10276,7 +10276,7 @@
                   <a:srgbClr val="595959"/>
                 </a:solidFill>
               </a:rPr>
-              <a:t>   . q = 0,95 : R = 5,45 % (21/385), gain 60 h sur 68 alertes</a:t>
+              <a:t>     (388 h a q=0,85, 269 h a q=0,99)</a:t>
             </a:r>
           </a:p>
           <a:p>
@@ -10287,7 +10287,7 @@
             </a:pPr>
             <a:r>
               <a:rPr sz="1500" b="0"/>
-              <a:t>   . q = 0,85 : R = 7,53 % (29/385), gain 118 h sur 140 alertes</a:t>
+              <a:t>   . Sweep theta strict : 2,86 % CG / 26 h sur 26 alertes (q=0,99), ou 7,53 % / 118 h sur 140 (q=0,85)</a:t>
             </a:r>
           </a:p>
           <a:p>
@@ -10302,7 +10302,7 @@
                   <a:srgbClr val="1F4E79"/>
                 </a:solidFill>
               </a:rPr>
-              <a:t>   . Baseline 30 min Meteorage : 0 % (0/385) — perfect par construction</a:t>
+              <a:t>   . Baseline 30 min Meteorage : 0 % de risque, 0 h de gain (reference)</a:t>
             </a:r>
           </a:p>
           <a:p>
@@ -10313,7 +10313,7 @@
             </a:pPr>
             <a:r>
               <a:rPr sz="1300" b="0"/>
-              <a:t>   . Demo Streamlit : on peut deplacer le slider q pour voir le compromis live</a:t>
+              <a:t>   . Demo Streamlit interactive : on deplace q pour voir le compromis live</a:t>
             </a:r>
           </a:p>
           <a:p>

</xml_diff>